<commit_message>
fix(pptx): eliminate text overlap — vertically centre cards on pin head
Root cause: text blocks were anchored at ty_pill = head_cy - 0.20 and
grew DOWNWARD, meaning above-pin descriptions crossed into the road
zone (y≈3.25), and below-pin text hit the slide footer.

Fix: each text block (pill + title + desc, total ≈1.35 in) is now
VERTICALLY CENTRED on head_cy, then clamped to stay within safe
margins (y 1.45 → 7.35). Text sits BESIDE the pin horizontally,
never above or below it, so it cannot cross the road zone regardless
of pin position.

Co-Authored-By: Claude Sonnet 4.6 <noreply@anthropic.com>
</commit_message>
<xml_diff>
--- a/Amorphis-Timeline.pptx
+++ b/Amorphis-Timeline.pptx
@@ -20106,8 +20106,8 @@
         </p:nvCxnSpPr>
         <p:spPr>
           <a:xfrm flipV="1">
-            <a:off x="1371600" y="1965960"/>
-            <a:ext cx="0" cy="804672"/>
+            <a:off x="1371600" y="1920240"/>
+            <a:ext cx="0" cy="850392"/>
           </a:xfrm>
           <a:prstGeom prst="line">
             <a:avLst/>
@@ -20141,7 +20141,7 @@
         </p:nvSpPr>
         <p:spPr>
           <a:xfrm>
-            <a:off x="1097280" y="1737360"/>
+            <a:off x="1097280" y="1691640"/>
             <a:ext cx="548640" cy="548640"/>
           </a:xfrm>
           <a:prstGeom prst="ellipse">
@@ -20184,7 +20184,7 @@
         </p:nvSpPr>
         <p:spPr>
           <a:xfrm>
-            <a:off x="1097280" y="1691639"/>
+            <a:off x="1097280" y="1645920"/>
             <a:ext cx="548640" cy="548640"/>
           </a:xfrm>
           <a:prstGeom prst="ellipse">
@@ -20229,7 +20229,7 @@
         </p:nvSpPr>
         <p:spPr>
           <a:xfrm>
-            <a:off x="1097280" y="1801368"/>
+            <a:off x="1097280" y="1755648"/>
             <a:ext cx="548640" cy="329184"/>
           </a:xfrm>
           <a:prstGeom prst="rect">
@@ -20264,8 +20264,8 @@
         </p:nvSpPr>
         <p:spPr>
           <a:xfrm>
-            <a:off x="1755648" y="1783080"/>
-            <a:ext cx="1188720" cy="256032"/>
+            <a:off x="1773936" y="1325880"/>
+            <a:ext cx="1188720" cy="237744"/>
           </a:xfrm>
           <a:prstGeom prst="roundRect">
             <a:avLst/>
@@ -20316,8 +20316,8 @@
         </p:nvSpPr>
         <p:spPr>
           <a:xfrm>
-            <a:off x="1755648" y="2093976"/>
-            <a:ext cx="1508760" cy="310896"/>
+            <a:off x="1773936" y="1618488"/>
+            <a:ext cx="1600200" cy="310896"/>
           </a:xfrm>
           <a:prstGeom prst="rect">
             <a:avLst/>
@@ -20332,7 +20332,7 @@
           <a:p>
             <a:pPr algn="l"/>
             <a:r>
-              <a:rPr sz="1400" b="1">
+              <a:rPr sz="1300" b="1">
                 <a:solidFill>
                   <a:srgbClr val="1F232B"/>
                 </a:solidFill>
@@ -20351,8 +20351,8 @@
         </p:nvSpPr>
         <p:spPr>
           <a:xfrm>
-            <a:off x="1755648" y="2423160"/>
-            <a:ext cx="1508760" cy="868680"/>
+            <a:off x="1773936" y="1965960"/>
+            <a:ext cx="1600200" cy="594360"/>
           </a:xfrm>
           <a:prstGeom prst="rect">
             <a:avLst/>
@@ -20387,7 +20387,7 @@
         <p:spPr>
           <a:xfrm>
             <a:off x="3383280" y="4956048"/>
-            <a:ext cx="0" cy="576072"/>
+            <a:ext cx="0" cy="621792"/>
           </a:xfrm>
           <a:prstGeom prst="line">
             <a:avLst/>
@@ -20421,7 +20421,7 @@
         </p:nvSpPr>
         <p:spPr>
           <a:xfrm>
-            <a:off x="3108960" y="5303520"/>
+            <a:off x="3108960" y="5349240"/>
             <a:ext cx="548640" cy="548640"/>
           </a:xfrm>
           <a:prstGeom prst="ellipse">
@@ -20464,7 +20464,7 @@
         </p:nvSpPr>
         <p:spPr>
           <a:xfrm>
-            <a:off x="3108960" y="5257800"/>
+            <a:off x="3108960" y="5303520"/>
             <a:ext cx="548640" cy="548640"/>
           </a:xfrm>
           <a:prstGeom prst="ellipse">
@@ -20509,7 +20509,7 @@
         </p:nvSpPr>
         <p:spPr>
           <a:xfrm>
-            <a:off x="3108960" y="5367528"/>
+            <a:off x="3108960" y="5413248"/>
             <a:ext cx="548640" cy="329184"/>
           </a:xfrm>
           <a:prstGeom prst="rect">
@@ -20544,8 +20544,8 @@
         </p:nvSpPr>
         <p:spPr>
           <a:xfrm>
-            <a:off x="3767328" y="5349240"/>
-            <a:ext cx="1188720" cy="256032"/>
+            <a:off x="3785615" y="4960620"/>
+            <a:ext cx="1188720" cy="237744"/>
           </a:xfrm>
           <a:prstGeom prst="roundRect">
             <a:avLst/>
@@ -20596,8 +20596,8 @@
         </p:nvSpPr>
         <p:spPr>
           <a:xfrm>
-            <a:off x="3767328" y="5660136"/>
-            <a:ext cx="1508760" cy="310896"/>
+            <a:off x="3785615" y="5253228"/>
+            <a:ext cx="1600200" cy="310896"/>
           </a:xfrm>
           <a:prstGeom prst="rect">
             <a:avLst/>
@@ -20612,7 +20612,7 @@
           <a:p>
             <a:pPr algn="l"/>
             <a:r>
-              <a:rPr sz="1400" b="1">
+              <a:rPr sz="1300" b="1">
                 <a:solidFill>
                   <a:srgbClr val="1F232B"/>
                 </a:solidFill>
@@ -20631,8 +20631,8 @@
         </p:nvSpPr>
         <p:spPr>
           <a:xfrm>
-            <a:off x="3767328" y="5989320"/>
-            <a:ext cx="1508760" cy="868680"/>
+            <a:off x="3785615" y="5600700"/>
+            <a:ext cx="1600200" cy="594360"/>
           </a:xfrm>
           <a:prstGeom prst="rect">
             <a:avLst/>
@@ -20666,8 +20666,8 @@
         </p:nvCxnSpPr>
         <p:spPr>
           <a:xfrm flipV="1">
-            <a:off x="5394960" y="1965960"/>
-            <a:ext cx="0" cy="804672"/>
+            <a:off x="5394960" y="1920240"/>
+            <a:ext cx="0" cy="850392"/>
           </a:xfrm>
           <a:prstGeom prst="line">
             <a:avLst/>
@@ -20701,7 +20701,7 @@
         </p:nvSpPr>
         <p:spPr>
           <a:xfrm>
-            <a:off x="5120640" y="1737360"/>
+            <a:off x="5120640" y="1691640"/>
             <a:ext cx="548640" cy="548640"/>
           </a:xfrm>
           <a:prstGeom prst="ellipse">
@@ -20744,7 +20744,7 @@
         </p:nvSpPr>
         <p:spPr>
           <a:xfrm>
-            <a:off x="5120640" y="1691639"/>
+            <a:off x="5120640" y="1645920"/>
             <a:ext cx="548640" cy="548640"/>
           </a:xfrm>
           <a:prstGeom prst="ellipse">
@@ -20789,7 +20789,7 @@
         </p:nvSpPr>
         <p:spPr>
           <a:xfrm>
-            <a:off x="5120640" y="1801368"/>
+            <a:off x="5120640" y="1755648"/>
             <a:ext cx="548640" cy="329184"/>
           </a:xfrm>
           <a:prstGeom prst="rect">
@@ -20824,8 +20824,8 @@
         </p:nvSpPr>
         <p:spPr>
           <a:xfrm>
-            <a:off x="5779008" y="1783080"/>
-            <a:ext cx="1188720" cy="256032"/>
+            <a:off x="5797296" y="1325880"/>
+            <a:ext cx="1188720" cy="237744"/>
           </a:xfrm>
           <a:prstGeom prst="roundRect">
             <a:avLst/>
@@ -20876,8 +20876,8 @@
         </p:nvSpPr>
         <p:spPr>
           <a:xfrm>
-            <a:off x="5779008" y="2093976"/>
-            <a:ext cx="1508760" cy="310896"/>
+            <a:off x="5797296" y="1618488"/>
+            <a:ext cx="1600200" cy="310896"/>
           </a:xfrm>
           <a:prstGeom prst="rect">
             <a:avLst/>
@@ -20892,7 +20892,7 @@
           <a:p>
             <a:pPr algn="l"/>
             <a:r>
-              <a:rPr sz="1400" b="1">
+              <a:rPr sz="1300" b="1">
                 <a:solidFill>
                   <a:srgbClr val="1F232B"/>
                 </a:solidFill>
@@ -20911,8 +20911,8 @@
         </p:nvSpPr>
         <p:spPr>
           <a:xfrm>
-            <a:off x="5779008" y="2423160"/>
-            <a:ext cx="1508760" cy="868680"/>
+            <a:off x="5797296" y="1965960"/>
+            <a:ext cx="1600200" cy="594360"/>
           </a:xfrm>
           <a:prstGeom prst="rect">
             <a:avLst/>
@@ -20947,7 +20947,7 @@
         <p:spPr>
           <a:xfrm>
             <a:off x="7406640" y="4956048"/>
-            <a:ext cx="0" cy="576072"/>
+            <a:ext cx="0" cy="621792"/>
           </a:xfrm>
           <a:prstGeom prst="line">
             <a:avLst/>
@@ -20981,7 +20981,7 @@
         </p:nvSpPr>
         <p:spPr>
           <a:xfrm>
-            <a:off x="7132320" y="5303520"/>
+            <a:off x="7132320" y="5349240"/>
             <a:ext cx="548640" cy="548640"/>
           </a:xfrm>
           <a:prstGeom prst="ellipse">
@@ -21024,7 +21024,7 @@
         </p:nvSpPr>
         <p:spPr>
           <a:xfrm>
-            <a:off x="7132320" y="5257800"/>
+            <a:off x="7132320" y="5303520"/>
             <a:ext cx="548640" cy="548640"/>
           </a:xfrm>
           <a:prstGeom prst="ellipse">
@@ -21069,7 +21069,7 @@
         </p:nvSpPr>
         <p:spPr>
           <a:xfrm>
-            <a:off x="7132320" y="5367528"/>
+            <a:off x="7132320" y="5413248"/>
             <a:ext cx="548640" cy="329184"/>
           </a:xfrm>
           <a:prstGeom prst="rect">
@@ -21104,8 +21104,8 @@
         </p:nvSpPr>
         <p:spPr>
           <a:xfrm>
-            <a:off x="7790688" y="5349240"/>
-            <a:ext cx="1188720" cy="256032"/>
+            <a:off x="7808976" y="4960620"/>
+            <a:ext cx="1188720" cy="237744"/>
           </a:xfrm>
           <a:prstGeom prst="roundRect">
             <a:avLst/>
@@ -21156,8 +21156,8 @@
         </p:nvSpPr>
         <p:spPr>
           <a:xfrm>
-            <a:off x="7790688" y="5660136"/>
-            <a:ext cx="1508760" cy="310896"/>
+            <a:off x="7808976" y="5253228"/>
+            <a:ext cx="1600200" cy="310896"/>
           </a:xfrm>
           <a:prstGeom prst="rect">
             <a:avLst/>
@@ -21172,7 +21172,7 @@
           <a:p>
             <a:pPr algn="l"/>
             <a:r>
-              <a:rPr sz="1400" b="1">
+              <a:rPr sz="1300" b="1">
                 <a:solidFill>
                   <a:srgbClr val="1F232B"/>
                 </a:solidFill>
@@ -21191,8 +21191,8 @@
         </p:nvSpPr>
         <p:spPr>
           <a:xfrm>
-            <a:off x="7790688" y="5989320"/>
-            <a:ext cx="1508760" cy="868680"/>
+            <a:off x="7808976" y="5600700"/>
+            <a:ext cx="1600200" cy="594360"/>
           </a:xfrm>
           <a:prstGeom prst="rect">
             <a:avLst/>
@@ -21226,8 +21226,8 @@
         </p:nvCxnSpPr>
         <p:spPr>
           <a:xfrm flipV="1">
-            <a:off x="9418320" y="1965960"/>
-            <a:ext cx="0" cy="804672"/>
+            <a:off x="9418320" y="1920240"/>
+            <a:ext cx="0" cy="850392"/>
           </a:xfrm>
           <a:prstGeom prst="line">
             <a:avLst/>
@@ -21261,7 +21261,7 @@
         </p:nvSpPr>
         <p:spPr>
           <a:xfrm>
-            <a:off x="9144000" y="1737360"/>
+            <a:off x="9144000" y="1691640"/>
             <a:ext cx="548640" cy="548640"/>
           </a:xfrm>
           <a:prstGeom prst="ellipse">
@@ -21304,7 +21304,7 @@
         </p:nvSpPr>
         <p:spPr>
           <a:xfrm>
-            <a:off x="9144000" y="1691639"/>
+            <a:off x="9144000" y="1645920"/>
             <a:ext cx="548640" cy="548640"/>
           </a:xfrm>
           <a:prstGeom prst="ellipse">
@@ -21349,7 +21349,7 @@
         </p:nvSpPr>
         <p:spPr>
           <a:xfrm>
-            <a:off x="9144000" y="1801368"/>
+            <a:off x="9144000" y="1755648"/>
             <a:ext cx="548640" cy="329184"/>
           </a:xfrm>
           <a:prstGeom prst="rect">
@@ -21384,8 +21384,8 @@
         </p:nvSpPr>
         <p:spPr>
           <a:xfrm>
-            <a:off x="9802368" y="1783080"/>
-            <a:ext cx="1188720" cy="256032"/>
+            <a:off x="9820656" y="1325880"/>
+            <a:ext cx="1188720" cy="237744"/>
           </a:xfrm>
           <a:prstGeom prst="roundRect">
             <a:avLst/>
@@ -21436,8 +21436,8 @@
         </p:nvSpPr>
         <p:spPr>
           <a:xfrm>
-            <a:off x="9802368" y="2093976"/>
-            <a:ext cx="1508760" cy="310896"/>
+            <a:off x="9820656" y="1618488"/>
+            <a:ext cx="1600200" cy="310896"/>
           </a:xfrm>
           <a:prstGeom prst="rect">
             <a:avLst/>
@@ -21452,7 +21452,7 @@
           <a:p>
             <a:pPr algn="l"/>
             <a:r>
-              <a:rPr sz="1400" b="1">
+              <a:rPr sz="1300" b="1">
                 <a:solidFill>
                   <a:srgbClr val="1F232B"/>
                 </a:solidFill>
@@ -21471,8 +21471,8 @@
         </p:nvSpPr>
         <p:spPr>
           <a:xfrm>
-            <a:off x="9802368" y="2423160"/>
-            <a:ext cx="1508760" cy="868680"/>
+            <a:off x="9820656" y="1965960"/>
+            <a:ext cx="1600200" cy="594360"/>
           </a:xfrm>
           <a:prstGeom prst="rect">
             <a:avLst/>
@@ -21507,7 +21507,7 @@
         <p:spPr>
           <a:xfrm>
             <a:off x="11430000" y="4956048"/>
-            <a:ext cx="0" cy="576072"/>
+            <a:ext cx="0" cy="621792"/>
           </a:xfrm>
           <a:prstGeom prst="line">
             <a:avLst/>
@@ -21541,7 +21541,7 @@
         </p:nvSpPr>
         <p:spPr>
           <a:xfrm>
-            <a:off x="11155680" y="5303520"/>
+            <a:off x="11155680" y="5349240"/>
             <a:ext cx="548640" cy="548640"/>
           </a:xfrm>
           <a:prstGeom prst="ellipse">
@@ -21584,7 +21584,7 @@
         </p:nvSpPr>
         <p:spPr>
           <a:xfrm>
-            <a:off x="11155680" y="5257800"/>
+            <a:off x="11155680" y="5303520"/>
             <a:ext cx="548640" cy="548640"/>
           </a:xfrm>
           <a:prstGeom prst="ellipse">
@@ -21629,7 +21629,7 @@
         </p:nvSpPr>
         <p:spPr>
           <a:xfrm>
-            <a:off x="11155680" y="5367528"/>
+            <a:off x="11155680" y="5413248"/>
             <a:ext cx="548640" cy="329184"/>
           </a:xfrm>
           <a:prstGeom prst="rect">
@@ -21664,8 +21664,8 @@
         </p:nvSpPr>
         <p:spPr>
           <a:xfrm>
-            <a:off x="9857232" y="5349240"/>
-            <a:ext cx="1188720" cy="256032"/>
+            <a:off x="9838943" y="4960620"/>
+            <a:ext cx="1188720" cy="237744"/>
           </a:xfrm>
           <a:prstGeom prst="roundRect">
             <a:avLst/>
@@ -21716,8 +21716,8 @@
         </p:nvSpPr>
         <p:spPr>
           <a:xfrm>
-            <a:off x="9537192" y="5660136"/>
-            <a:ext cx="1508760" cy="310896"/>
+            <a:off x="9427463" y="5253228"/>
+            <a:ext cx="1600200" cy="310896"/>
           </a:xfrm>
           <a:prstGeom prst="rect">
             <a:avLst/>
@@ -21732,7 +21732,7 @@
           <a:p>
             <a:pPr algn="r"/>
             <a:r>
-              <a:rPr sz="1400" b="1">
+              <a:rPr sz="1300" b="1">
                 <a:solidFill>
                   <a:srgbClr val="1F232B"/>
                 </a:solidFill>
@@ -21751,8 +21751,8 @@
         </p:nvSpPr>
         <p:spPr>
           <a:xfrm>
-            <a:off x="9537192" y="5989320"/>
-            <a:ext cx="1508760" cy="868680"/>
+            <a:off x="9427463" y="5600700"/>
+            <a:ext cx="1600200" cy="594360"/>
           </a:xfrm>
           <a:prstGeom prst="rect">
             <a:avLst/>
@@ -38883,8 +38883,8 @@
         </p:nvCxnSpPr>
         <p:spPr>
           <a:xfrm flipV="1">
-            <a:off x="1371600" y="1965960"/>
-            <a:ext cx="0" cy="804672"/>
+            <a:off x="1371600" y="1920240"/>
+            <a:ext cx="0" cy="850392"/>
           </a:xfrm>
           <a:prstGeom prst="line">
             <a:avLst/>
@@ -38918,7 +38918,7 @@
         </p:nvSpPr>
         <p:spPr>
           <a:xfrm>
-            <a:off x="1097280" y="1737360"/>
+            <a:off x="1097280" y="1691640"/>
             <a:ext cx="548640" cy="548640"/>
           </a:xfrm>
           <a:prstGeom prst="ellipse">
@@ -38961,7 +38961,7 @@
         </p:nvSpPr>
         <p:spPr>
           <a:xfrm>
-            <a:off x="1097280" y="1691639"/>
+            <a:off x="1097280" y="1645920"/>
             <a:ext cx="548640" cy="548640"/>
           </a:xfrm>
           <a:prstGeom prst="ellipse">
@@ -39006,7 +39006,7 @@
         </p:nvSpPr>
         <p:spPr>
           <a:xfrm>
-            <a:off x="1097280" y="1801368"/>
+            <a:off x="1097280" y="1755648"/>
             <a:ext cx="548640" cy="329184"/>
           </a:xfrm>
           <a:prstGeom prst="rect">
@@ -39041,8 +39041,8 @@
         </p:nvSpPr>
         <p:spPr>
           <a:xfrm>
-            <a:off x="1755648" y="1783080"/>
-            <a:ext cx="1188720" cy="256032"/>
+            <a:off x="1773936" y="1325880"/>
+            <a:ext cx="1188720" cy="237744"/>
           </a:xfrm>
           <a:prstGeom prst="roundRect">
             <a:avLst/>
@@ -39093,8 +39093,8 @@
         </p:nvSpPr>
         <p:spPr>
           <a:xfrm>
-            <a:off x="1755648" y="2093976"/>
-            <a:ext cx="1508760" cy="310896"/>
+            <a:off x="1773936" y="1618488"/>
+            <a:ext cx="1600200" cy="310896"/>
           </a:xfrm>
           <a:prstGeom prst="rect">
             <a:avLst/>
@@ -39109,7 +39109,7 @@
           <a:p>
             <a:pPr algn="l"/>
             <a:r>
-              <a:rPr sz="1400" b="1">
+              <a:rPr sz="1300" b="1">
                 <a:solidFill>
                   <a:srgbClr val="1F232B"/>
                 </a:solidFill>
@@ -39128,8 +39128,8 @@
         </p:nvSpPr>
         <p:spPr>
           <a:xfrm>
-            <a:off x="1755648" y="2423160"/>
-            <a:ext cx="1508760" cy="868680"/>
+            <a:off x="1773936" y="1965960"/>
+            <a:ext cx="1600200" cy="594360"/>
           </a:xfrm>
           <a:prstGeom prst="rect">
             <a:avLst/>
@@ -39164,7 +39164,7 @@
         <p:spPr>
           <a:xfrm>
             <a:off x="3383280" y="4956048"/>
-            <a:ext cx="0" cy="576072"/>
+            <a:ext cx="0" cy="621792"/>
           </a:xfrm>
           <a:prstGeom prst="line">
             <a:avLst/>
@@ -39198,7 +39198,7 @@
         </p:nvSpPr>
         <p:spPr>
           <a:xfrm>
-            <a:off x="3108960" y="5303520"/>
+            <a:off x="3108960" y="5349240"/>
             <a:ext cx="548640" cy="548640"/>
           </a:xfrm>
           <a:prstGeom prst="ellipse">
@@ -39241,7 +39241,7 @@
         </p:nvSpPr>
         <p:spPr>
           <a:xfrm>
-            <a:off x="3108960" y="5257800"/>
+            <a:off x="3108960" y="5303520"/>
             <a:ext cx="548640" cy="548640"/>
           </a:xfrm>
           <a:prstGeom prst="ellipse">
@@ -39286,7 +39286,7 @@
         </p:nvSpPr>
         <p:spPr>
           <a:xfrm>
-            <a:off x="3108960" y="5367528"/>
+            <a:off x="3108960" y="5413248"/>
             <a:ext cx="548640" cy="329184"/>
           </a:xfrm>
           <a:prstGeom prst="rect">
@@ -39321,8 +39321,8 @@
         </p:nvSpPr>
         <p:spPr>
           <a:xfrm>
-            <a:off x="3767328" y="5349240"/>
-            <a:ext cx="1188720" cy="256032"/>
+            <a:off x="3785615" y="4960620"/>
+            <a:ext cx="1188720" cy="237744"/>
           </a:xfrm>
           <a:prstGeom prst="roundRect">
             <a:avLst/>
@@ -39373,8 +39373,8 @@
         </p:nvSpPr>
         <p:spPr>
           <a:xfrm>
-            <a:off x="3767328" y="5660136"/>
-            <a:ext cx="1508760" cy="310896"/>
+            <a:off x="3785615" y="5253228"/>
+            <a:ext cx="1600200" cy="310896"/>
           </a:xfrm>
           <a:prstGeom prst="rect">
             <a:avLst/>
@@ -39389,7 +39389,7 @@
           <a:p>
             <a:pPr algn="l"/>
             <a:r>
-              <a:rPr sz="1400" b="1">
+              <a:rPr sz="1300" b="1">
                 <a:solidFill>
                   <a:srgbClr val="1F232B"/>
                 </a:solidFill>
@@ -39408,8 +39408,8 @@
         </p:nvSpPr>
         <p:spPr>
           <a:xfrm>
-            <a:off x="3767328" y="5989320"/>
-            <a:ext cx="1508760" cy="868680"/>
+            <a:off x="3785615" y="5600700"/>
+            <a:ext cx="1600200" cy="594360"/>
           </a:xfrm>
           <a:prstGeom prst="rect">
             <a:avLst/>
@@ -39443,8 +39443,8 @@
         </p:nvCxnSpPr>
         <p:spPr>
           <a:xfrm flipV="1">
-            <a:off x="5394960" y="1965960"/>
-            <a:ext cx="0" cy="804672"/>
+            <a:off x="5394960" y="1920240"/>
+            <a:ext cx="0" cy="850392"/>
           </a:xfrm>
           <a:prstGeom prst="line">
             <a:avLst/>
@@ -39478,7 +39478,7 @@
         </p:nvSpPr>
         <p:spPr>
           <a:xfrm>
-            <a:off x="5120640" y="1737360"/>
+            <a:off x="5120640" y="1691640"/>
             <a:ext cx="548640" cy="548640"/>
           </a:xfrm>
           <a:prstGeom prst="ellipse">
@@ -39521,7 +39521,7 @@
         </p:nvSpPr>
         <p:spPr>
           <a:xfrm>
-            <a:off x="5120640" y="1691639"/>
+            <a:off x="5120640" y="1645920"/>
             <a:ext cx="548640" cy="548640"/>
           </a:xfrm>
           <a:prstGeom prst="ellipse">
@@ -39566,7 +39566,7 @@
         </p:nvSpPr>
         <p:spPr>
           <a:xfrm>
-            <a:off x="5120640" y="1801368"/>
+            <a:off x="5120640" y="1755648"/>
             <a:ext cx="548640" cy="329184"/>
           </a:xfrm>
           <a:prstGeom prst="rect">
@@ -39601,8 +39601,8 @@
         </p:nvSpPr>
         <p:spPr>
           <a:xfrm>
-            <a:off x="5779008" y="1783080"/>
-            <a:ext cx="1188720" cy="256032"/>
+            <a:off x="5797296" y="1325880"/>
+            <a:ext cx="1188720" cy="237744"/>
           </a:xfrm>
           <a:prstGeom prst="roundRect">
             <a:avLst/>
@@ -39653,8 +39653,8 @@
         </p:nvSpPr>
         <p:spPr>
           <a:xfrm>
-            <a:off x="5779008" y="2093976"/>
-            <a:ext cx="1508760" cy="310896"/>
+            <a:off x="5797296" y="1618488"/>
+            <a:ext cx="1600200" cy="310896"/>
           </a:xfrm>
           <a:prstGeom prst="rect">
             <a:avLst/>
@@ -39669,7 +39669,7 @@
           <a:p>
             <a:pPr algn="l"/>
             <a:r>
-              <a:rPr sz="1400" b="1">
+              <a:rPr sz="1300" b="1">
                 <a:solidFill>
                   <a:srgbClr val="1F232B"/>
                 </a:solidFill>
@@ -39688,8 +39688,8 @@
         </p:nvSpPr>
         <p:spPr>
           <a:xfrm>
-            <a:off x="5779008" y="2423160"/>
-            <a:ext cx="1508760" cy="868680"/>
+            <a:off x="5797296" y="1965960"/>
+            <a:ext cx="1600200" cy="594360"/>
           </a:xfrm>
           <a:prstGeom prst="rect">
             <a:avLst/>
@@ -39724,7 +39724,7 @@
         <p:spPr>
           <a:xfrm>
             <a:off x="7406640" y="4956048"/>
-            <a:ext cx="0" cy="576072"/>
+            <a:ext cx="0" cy="621792"/>
           </a:xfrm>
           <a:prstGeom prst="line">
             <a:avLst/>
@@ -39758,7 +39758,7 @@
         </p:nvSpPr>
         <p:spPr>
           <a:xfrm>
-            <a:off x="7132320" y="5303520"/>
+            <a:off x="7132320" y="5349240"/>
             <a:ext cx="548640" cy="548640"/>
           </a:xfrm>
           <a:prstGeom prst="ellipse">
@@ -39801,7 +39801,7 @@
         </p:nvSpPr>
         <p:spPr>
           <a:xfrm>
-            <a:off x="7132320" y="5257800"/>
+            <a:off x="7132320" y="5303520"/>
             <a:ext cx="548640" cy="548640"/>
           </a:xfrm>
           <a:prstGeom prst="ellipse">
@@ -39846,7 +39846,7 @@
         </p:nvSpPr>
         <p:spPr>
           <a:xfrm>
-            <a:off x="7132320" y="5367528"/>
+            <a:off x="7132320" y="5413248"/>
             <a:ext cx="548640" cy="329184"/>
           </a:xfrm>
           <a:prstGeom prst="rect">
@@ -39881,8 +39881,8 @@
         </p:nvSpPr>
         <p:spPr>
           <a:xfrm>
-            <a:off x="7790688" y="5349240"/>
-            <a:ext cx="1188720" cy="256032"/>
+            <a:off x="7808976" y="4960620"/>
+            <a:ext cx="1188720" cy="237744"/>
           </a:xfrm>
           <a:prstGeom prst="roundRect">
             <a:avLst/>
@@ -39933,8 +39933,8 @@
         </p:nvSpPr>
         <p:spPr>
           <a:xfrm>
-            <a:off x="7790688" y="5660136"/>
-            <a:ext cx="1508760" cy="310896"/>
+            <a:off x="7808976" y="5253228"/>
+            <a:ext cx="1600200" cy="310896"/>
           </a:xfrm>
           <a:prstGeom prst="rect">
             <a:avLst/>
@@ -39949,7 +39949,7 @@
           <a:p>
             <a:pPr algn="l"/>
             <a:r>
-              <a:rPr sz="1400" b="1">
+              <a:rPr sz="1300" b="1">
                 <a:solidFill>
                   <a:srgbClr val="1F232B"/>
                 </a:solidFill>
@@ -39968,8 +39968,8 @@
         </p:nvSpPr>
         <p:spPr>
           <a:xfrm>
-            <a:off x="7790688" y="5989320"/>
-            <a:ext cx="1508760" cy="868680"/>
+            <a:off x="7808976" y="5600700"/>
+            <a:ext cx="1600200" cy="594360"/>
           </a:xfrm>
           <a:prstGeom prst="rect">
             <a:avLst/>
@@ -40003,8 +40003,8 @@
         </p:nvCxnSpPr>
         <p:spPr>
           <a:xfrm flipV="1">
-            <a:off x="9418320" y="1965960"/>
-            <a:ext cx="0" cy="804672"/>
+            <a:off x="9418320" y="1920240"/>
+            <a:ext cx="0" cy="850392"/>
           </a:xfrm>
           <a:prstGeom prst="line">
             <a:avLst/>
@@ -40038,7 +40038,7 @@
         </p:nvSpPr>
         <p:spPr>
           <a:xfrm>
-            <a:off x="9144000" y="1737360"/>
+            <a:off x="9144000" y="1691640"/>
             <a:ext cx="548640" cy="548640"/>
           </a:xfrm>
           <a:prstGeom prst="ellipse">
@@ -40081,7 +40081,7 @@
         </p:nvSpPr>
         <p:spPr>
           <a:xfrm>
-            <a:off x="9144000" y="1691639"/>
+            <a:off x="9144000" y="1645920"/>
             <a:ext cx="548640" cy="548640"/>
           </a:xfrm>
           <a:prstGeom prst="ellipse">
@@ -40126,7 +40126,7 @@
         </p:nvSpPr>
         <p:spPr>
           <a:xfrm>
-            <a:off x="9144000" y="1801368"/>
+            <a:off x="9144000" y="1755648"/>
             <a:ext cx="548640" cy="329184"/>
           </a:xfrm>
           <a:prstGeom prst="rect">
@@ -40161,8 +40161,8 @@
         </p:nvSpPr>
         <p:spPr>
           <a:xfrm>
-            <a:off x="9802368" y="1783080"/>
-            <a:ext cx="1188720" cy="256032"/>
+            <a:off x="9820656" y="1325880"/>
+            <a:ext cx="1188720" cy="237744"/>
           </a:xfrm>
           <a:prstGeom prst="roundRect">
             <a:avLst/>
@@ -40213,8 +40213,8 @@
         </p:nvSpPr>
         <p:spPr>
           <a:xfrm>
-            <a:off x="9802368" y="2093976"/>
-            <a:ext cx="1508760" cy="310896"/>
+            <a:off x="9820656" y="1618488"/>
+            <a:ext cx="1600200" cy="310896"/>
           </a:xfrm>
           <a:prstGeom prst="rect">
             <a:avLst/>
@@ -40229,7 +40229,7 @@
           <a:p>
             <a:pPr algn="l"/>
             <a:r>
-              <a:rPr sz="1400" b="1">
+              <a:rPr sz="1300" b="1">
                 <a:solidFill>
                   <a:srgbClr val="1F232B"/>
                 </a:solidFill>
@@ -40248,8 +40248,8 @@
         </p:nvSpPr>
         <p:spPr>
           <a:xfrm>
-            <a:off x="9802368" y="2423160"/>
-            <a:ext cx="1508760" cy="868680"/>
+            <a:off x="9820656" y="1965960"/>
+            <a:ext cx="1600200" cy="594360"/>
           </a:xfrm>
           <a:prstGeom prst="rect">
             <a:avLst/>
@@ -40284,7 +40284,7 @@
         <p:spPr>
           <a:xfrm>
             <a:off x="11430000" y="4956048"/>
-            <a:ext cx="0" cy="576072"/>
+            <a:ext cx="0" cy="621792"/>
           </a:xfrm>
           <a:prstGeom prst="line">
             <a:avLst/>
@@ -40318,7 +40318,7 @@
         </p:nvSpPr>
         <p:spPr>
           <a:xfrm>
-            <a:off x="11155680" y="5303520"/>
+            <a:off x="11155680" y="5349240"/>
             <a:ext cx="548640" cy="548640"/>
           </a:xfrm>
           <a:prstGeom prst="ellipse">
@@ -40361,7 +40361,7 @@
         </p:nvSpPr>
         <p:spPr>
           <a:xfrm>
-            <a:off x="11155680" y="5257800"/>
+            <a:off x="11155680" y="5303520"/>
             <a:ext cx="548640" cy="548640"/>
           </a:xfrm>
           <a:prstGeom prst="ellipse">
@@ -40406,7 +40406,7 @@
         </p:nvSpPr>
         <p:spPr>
           <a:xfrm>
-            <a:off x="11155680" y="5367528"/>
+            <a:off x="11155680" y="5413248"/>
             <a:ext cx="548640" cy="329184"/>
           </a:xfrm>
           <a:prstGeom prst="rect">
@@ -40441,8 +40441,8 @@
         </p:nvSpPr>
         <p:spPr>
           <a:xfrm>
-            <a:off x="9857232" y="5349240"/>
-            <a:ext cx="1188720" cy="256032"/>
+            <a:off x="9838943" y="4960620"/>
+            <a:ext cx="1188720" cy="237744"/>
           </a:xfrm>
           <a:prstGeom prst="roundRect">
             <a:avLst/>
@@ -40493,8 +40493,8 @@
         </p:nvSpPr>
         <p:spPr>
           <a:xfrm>
-            <a:off x="9537192" y="5660136"/>
-            <a:ext cx="1508760" cy="310896"/>
+            <a:off x="9427463" y="5253228"/>
+            <a:ext cx="1600200" cy="310896"/>
           </a:xfrm>
           <a:prstGeom prst="rect">
             <a:avLst/>
@@ -40509,7 +40509,7 @@
           <a:p>
             <a:pPr algn="r"/>
             <a:r>
-              <a:rPr sz="1400" b="1">
+              <a:rPr sz="1300" b="1">
                 <a:solidFill>
                   <a:srgbClr val="1F232B"/>
                 </a:solidFill>
@@ -40528,8 +40528,8 @@
         </p:nvSpPr>
         <p:spPr>
           <a:xfrm>
-            <a:off x="9537192" y="5989320"/>
-            <a:ext cx="1508760" cy="868680"/>
+            <a:off x="9427463" y="5600700"/>
+            <a:ext cx="1600200" cy="594360"/>
           </a:xfrm>
           <a:prstGeom prst="rect">
             <a:avLst/>

</xml_diff>